<commit_message>
Enhance demo runbook and agent instructions; update JSON-RPC handling in client/server
</commit_message>
<xml_diff>
--- a/ai-agent-terms-conference-talk.pptx
+++ b/ai-agent-terms-conference-talk.pptx
@@ -2,25 +2,25 @@
 <file path=ppt/presentation.xml><?xml version="1.0" encoding="utf-8"?>
 <p:presentation xmlns:p="http://schemas.openxmlformats.org/presentationml/2006/main">
   <p:sldMasterIdLst>
-    <p:sldMasterId xmlns:r="http://schemas.openxmlformats.org/officeDocument/2006/relationships" id="2147483648" r:id="R13352d41616c4a75"/>
+    <p:sldMasterId xmlns:r="http://schemas.openxmlformats.org/officeDocument/2006/relationships" id="2147483648" r:id="Rfad0bdf6b0664dac"/>
   </p:sldMasterIdLst>
   <p:notesMasterIdLst>
-    <p:notesMasterId xmlns:r="http://schemas.openxmlformats.org/officeDocument/2006/relationships" r:id="R47ffd5bb48104fc8"/>
+    <p:notesMasterId xmlns:r="http://schemas.openxmlformats.org/officeDocument/2006/relationships" r:id="R62a02a58406944e2"/>
   </p:notesMasterIdLst>
   <p:sldIdLst>
-    <p:sldId xmlns:r="http://schemas.openxmlformats.org/officeDocument/2006/relationships" id="256" r:id="Rc5f9d8adeb474bfd"/>
-    <p:sldId xmlns:r="http://schemas.openxmlformats.org/officeDocument/2006/relationships" id="257" r:id="R39cbebe9ab9b47b5"/>
-    <p:sldId xmlns:r="http://schemas.openxmlformats.org/officeDocument/2006/relationships" id="258" r:id="R4846099cdff44201"/>
-    <p:sldId xmlns:r="http://schemas.openxmlformats.org/officeDocument/2006/relationships" id="259" r:id="R80031fa3bec84338"/>
-    <p:sldId xmlns:r="http://schemas.openxmlformats.org/officeDocument/2006/relationships" id="260" r:id="R206db2c308cd47bd"/>
-    <p:sldId xmlns:r="http://schemas.openxmlformats.org/officeDocument/2006/relationships" id="261" r:id="R8f734b74dc7741c8"/>
-    <p:sldId xmlns:r="http://schemas.openxmlformats.org/officeDocument/2006/relationships" id="262" r:id="R4c069ec0536d4029"/>
-    <p:sldId xmlns:r="http://schemas.openxmlformats.org/officeDocument/2006/relationships" id="263" r:id="Rce02d00959d74564"/>
-    <p:sldId xmlns:r="http://schemas.openxmlformats.org/officeDocument/2006/relationships" id="264" r:id="R5cbd63f2f1cc4300"/>
-    <p:sldId xmlns:r="http://schemas.openxmlformats.org/officeDocument/2006/relationships" id="265" r:id="R4cb854b2bbe640fc"/>
-    <p:sldId xmlns:r="http://schemas.openxmlformats.org/officeDocument/2006/relationships" id="266" r:id="Ra2f987ee60a94217"/>
-    <p:sldId xmlns:r="http://schemas.openxmlformats.org/officeDocument/2006/relationships" id="267" r:id="R5f31888b1f104a8e"/>
-    <p:sldId xmlns:r="http://schemas.openxmlformats.org/officeDocument/2006/relationships" id="268" r:id="R59e98b6bff174c26"/>
+    <p:sldId xmlns:r="http://schemas.openxmlformats.org/officeDocument/2006/relationships" id="256" r:id="R6f0b677dafcf42f4"/>
+    <p:sldId xmlns:r="http://schemas.openxmlformats.org/officeDocument/2006/relationships" id="257" r:id="R2e3ac7b2e2c54617"/>
+    <p:sldId xmlns:r="http://schemas.openxmlformats.org/officeDocument/2006/relationships" id="258" r:id="R8f456186ddd44289"/>
+    <p:sldId xmlns:r="http://schemas.openxmlformats.org/officeDocument/2006/relationships" id="259" r:id="R8281fc70aac74dff"/>
+    <p:sldId xmlns:r="http://schemas.openxmlformats.org/officeDocument/2006/relationships" id="260" r:id="R8e22c65fc27c460d"/>
+    <p:sldId xmlns:r="http://schemas.openxmlformats.org/officeDocument/2006/relationships" id="261" r:id="R498d78172b5f46e5"/>
+    <p:sldId xmlns:r="http://schemas.openxmlformats.org/officeDocument/2006/relationships" id="262" r:id="R6abe605a612643c8"/>
+    <p:sldId xmlns:r="http://schemas.openxmlformats.org/officeDocument/2006/relationships" id="263" r:id="R509272fbeb3f4f1c"/>
+    <p:sldId xmlns:r="http://schemas.openxmlformats.org/officeDocument/2006/relationships" id="264" r:id="Ree4d05c4ccb945ff"/>
+    <p:sldId xmlns:r="http://schemas.openxmlformats.org/officeDocument/2006/relationships" id="265" r:id="Rb72d2eb8ec084ac4"/>
+    <p:sldId xmlns:r="http://schemas.openxmlformats.org/officeDocument/2006/relationships" id="266" r:id="R47895bd608e946b5"/>
+    <p:sldId xmlns:r="http://schemas.openxmlformats.org/officeDocument/2006/relationships" id="267" r:id="R9faf88aa660440c5"/>
+    <p:sldId xmlns:r="http://schemas.openxmlformats.org/officeDocument/2006/relationships" id="268" r:id="R4d42609ca77545b1"/>
   </p:sldIdLst>
   <p:sldSz cx="12192000" cy="6858000"/>
   <p:notesSz cx="6858000" cy="9144000"/>
@@ -1582,7 +1582,7 @@
   </p:cSld>
   <p:clrMap bg1="lt1" tx1="dk1" bg2="lt2" tx2="dk2" accent1="accent1" accent2="accent2" accent3="accent3" accent4="accent4" accent5="accent5" accent6="accent6" hlink="hlink" folHlink="folHlink"/>
   <p:sldLayoutIdLst>
-    <p:sldLayoutId xmlns:r="http://schemas.openxmlformats.org/officeDocument/2006/relationships" id="2147483649" r:id="Rf3428e642cc846c2"/>
+    <p:sldLayoutId xmlns:r="http://schemas.openxmlformats.org/officeDocument/2006/relationships" id="2147483649" r:id="Re6f6e35e6b4c4beb"/>
   </p:sldLayoutIdLst>
   <p:txStyles>
     <p:titleStyle>
@@ -2161,6 +2161,7 @@
           <a:lstStyle xmlns:a="http://schemas.openxmlformats.org/drawingml/2006/main"/>
           <a:p xmlns:a="http://schemas.openxmlformats.org/drawingml/2006/main">
             <a:pPr algn="l">
+              <a:buNone/>
               <a:defRPr sz="5100" b="1">
                 <a:solidFill>
                   <a:srgbClr val="000000"/>
@@ -2242,6 +2243,7 @@
           <a:lstStyle xmlns:a="http://schemas.openxmlformats.org/drawingml/2006/main"/>
           <a:p xmlns:a="http://schemas.openxmlformats.org/drawingml/2006/main">
             <a:pPr algn="l">
+              <a:buNone/>
               <a:defRPr sz="1800" b="0">
                 <a:solidFill>
                   <a:srgbClr val="222222"/>
@@ -2323,6 +2325,7 @@
           <a:lstStyle xmlns:a="http://schemas.openxmlformats.org/drawingml/2006/main"/>
           <a:p xmlns:a="http://schemas.openxmlformats.org/drawingml/2006/main">
             <a:pPr algn="l">
+              <a:buNone/>
               <a:defRPr sz="2100" b="0">
                 <a:solidFill>
                   <a:srgbClr val="000000"/>
@@ -2373,6 +2376,7 @@
           <a:lstStyle xmlns:a="http://schemas.openxmlformats.org/drawingml/2006/main"/>
           <a:p xmlns:a="http://schemas.openxmlformats.org/drawingml/2006/main">
             <a:pPr algn="l">
+              <a:buNone/>
               <a:defRPr sz="2100" b="0">
                 <a:solidFill>
                   <a:srgbClr val="000000"/>
@@ -2423,6 +2427,7 @@
           <a:lstStyle xmlns:a="http://schemas.openxmlformats.org/drawingml/2006/main"/>
           <a:p xmlns:a="http://schemas.openxmlformats.org/drawingml/2006/main">
             <a:pPr algn="l">
+              <a:buNone/>
               <a:defRPr sz="2100" b="0">
                 <a:solidFill>
                   <a:srgbClr val="000000"/>
@@ -2535,6 +2540,7 @@
           <a:lstStyle xmlns:a="http://schemas.openxmlformats.org/drawingml/2006/main"/>
           <a:p xmlns:a="http://schemas.openxmlformats.org/drawingml/2006/main">
             <a:pPr algn="l">
+              <a:buNone/>
               <a:defRPr sz="1500" b="0">
                 <a:solidFill>
                   <a:srgbClr val="555555"/>
@@ -2585,6 +2591,7 @@
           <a:lstStyle xmlns:a="http://schemas.openxmlformats.org/drawingml/2006/main"/>
           <a:p xmlns:a="http://schemas.openxmlformats.org/drawingml/2006/main">
             <a:pPr algn="l">
+              <a:buNone/>
               <a:defRPr sz="1500" b="0">
                 <a:solidFill>
                   <a:srgbClr val="555555"/>
@@ -2635,6 +2642,7 @@
           <a:lstStyle xmlns:a="http://schemas.openxmlformats.org/drawingml/2006/main"/>
           <a:p xmlns:a="http://schemas.openxmlformats.org/drawingml/2006/main">
             <a:pPr algn="l">
+              <a:buNone/>
               <a:defRPr sz="1500" b="0">
                 <a:solidFill>
                   <a:srgbClr val="555555"/>
@@ -2685,6 +2693,7 @@
           <a:lstStyle xmlns:a="http://schemas.openxmlformats.org/drawingml/2006/main"/>
           <a:p xmlns:a="http://schemas.openxmlformats.org/drawingml/2006/main">
             <a:pPr algn="l">
+              <a:buNone/>
               <a:defRPr sz="1125" b="0">
                 <a:solidFill>
                   <a:srgbClr val="555555"/>
@@ -2735,6 +2744,7 @@
           <a:lstStyle xmlns:a="http://schemas.openxmlformats.org/drawingml/2006/main"/>
           <a:p xmlns:a="http://schemas.openxmlformats.org/drawingml/2006/main">
             <a:pPr algn="r">
+              <a:buNone/>
               <a:defRPr sz="1125" b="0">
                 <a:solidFill>
                   <a:srgbClr val="000000"/>
@@ -2814,6 +2824,7 @@
           <a:lstStyle xmlns:a="http://schemas.openxmlformats.org/drawingml/2006/main"/>
           <a:p xmlns:a="http://schemas.openxmlformats.org/drawingml/2006/main">
             <a:pPr algn="l">
+              <a:buNone/>
               <a:defRPr sz="2925" b="0">
                 <a:solidFill>
                   <a:srgbClr val="000000"/>
@@ -2864,6 +2875,7 @@
           <a:lstStyle xmlns:a="http://schemas.openxmlformats.org/drawingml/2006/main"/>
           <a:p xmlns:a="http://schemas.openxmlformats.org/drawingml/2006/main">
             <a:pPr algn="l">
+              <a:buNone/>
               <a:defRPr sz="1650" b="0">
                 <a:solidFill>
                   <a:srgbClr val="555555"/>
@@ -2914,6 +2926,7 @@
           <a:lstStyle xmlns:a="http://schemas.openxmlformats.org/drawingml/2006/main"/>
           <a:p xmlns:a="http://schemas.openxmlformats.org/drawingml/2006/main">
             <a:pPr algn="l">
+              <a:buNone/>
               <a:defRPr sz="1125" b="0">
                 <a:solidFill>
                   <a:srgbClr val="555555"/>
@@ -2964,6 +2977,7 @@
           <a:lstStyle xmlns:a="http://schemas.openxmlformats.org/drawingml/2006/main"/>
           <a:p xmlns:a="http://schemas.openxmlformats.org/drawingml/2006/main">
             <a:pPr algn="r">
+              <a:buNone/>
               <a:defRPr sz="1125" b="0">
                 <a:solidFill>
                   <a:srgbClr val="000000"/>
@@ -3045,6 +3059,7 @@
           <a:lstStyle xmlns:a="http://schemas.openxmlformats.org/drawingml/2006/main"/>
           <a:p xmlns:a="http://schemas.openxmlformats.org/drawingml/2006/main">
             <a:pPr algn="l">
+              <a:buNone/>
               <a:defRPr sz="1200" b="1">
                 <a:solidFill>
                   <a:srgbClr val="FFFFFF"/>
@@ -3095,6 +3110,7 @@
           <a:lstStyle xmlns:a="http://schemas.openxmlformats.org/drawingml/2006/main"/>
           <a:p xmlns:a="http://schemas.openxmlformats.org/drawingml/2006/main">
             <a:pPr algn="l">
+              <a:buNone/>
               <a:defRPr sz="1350" b="0">
                 <a:solidFill>
                   <a:srgbClr val="FFFFFF"/>
@@ -3117,6 +3133,7 @@
           </a:p>
           <a:p xmlns:a="http://schemas.openxmlformats.org/drawingml/2006/main">
             <a:pPr algn="l">
+              <a:buNone/>
               <a:defRPr sz="1350" b="0">
                 <a:solidFill>
                   <a:srgbClr val="FFFFFF"/>
@@ -3134,6 +3151,7 @@
           </a:p>
           <a:p xmlns:a="http://schemas.openxmlformats.org/drawingml/2006/main">
             <a:pPr algn="l">
+              <a:buNone/>
               <a:defRPr sz="1350" b="0">
                 <a:solidFill>
                   <a:srgbClr val="FFFFFF"/>
@@ -3156,6 +3174,7 @@
           </a:p>
           <a:p xmlns:a="http://schemas.openxmlformats.org/drawingml/2006/main">
             <a:pPr algn="l">
+              <a:buNone/>
               <a:defRPr sz="1350" b="0">
                 <a:solidFill>
                   <a:srgbClr val="FFFFFF"/>
@@ -3173,6 +3192,7 @@
           </a:p>
           <a:p xmlns:a="http://schemas.openxmlformats.org/drawingml/2006/main">
             <a:pPr algn="l">
+              <a:buNone/>
               <a:defRPr sz="1350" b="0">
                 <a:solidFill>
                   <a:srgbClr val="FFFFFF"/>
@@ -3190,6 +3210,7 @@
           </a:p>
           <a:p xmlns:a="http://schemas.openxmlformats.org/drawingml/2006/main">
             <a:pPr algn="l">
+              <a:buNone/>
               <a:defRPr sz="1350" b="0">
                 <a:solidFill>
                   <a:srgbClr val="FFFFFF"/>
@@ -3207,6 +3228,7 @@
           </a:p>
           <a:p xmlns:a="http://schemas.openxmlformats.org/drawingml/2006/main">
             <a:pPr algn="l">
+              <a:buNone/>
               <a:defRPr sz="1350" b="0">
                 <a:solidFill>
                   <a:srgbClr val="FFFFFF"/>
@@ -3288,6 +3310,7 @@
           <a:lstStyle xmlns:a="http://schemas.openxmlformats.org/drawingml/2006/main"/>
           <a:p xmlns:a="http://schemas.openxmlformats.org/drawingml/2006/main">
             <a:pPr algn="l">
+              <a:buNone/>
               <a:defRPr sz="2100" b="0">
                 <a:solidFill>
                   <a:srgbClr val="000000"/>
@@ -3338,6 +3361,7 @@
           <a:lstStyle xmlns:a="http://schemas.openxmlformats.org/drawingml/2006/main"/>
           <a:p xmlns:a="http://schemas.openxmlformats.org/drawingml/2006/main">
             <a:pPr algn="l">
+              <a:buNone/>
               <a:defRPr sz="1725" b="0">
                 <a:solidFill>
                   <a:srgbClr val="222222"/>
@@ -3421,6 +3445,7 @@
           <a:lstStyle xmlns:a="http://schemas.openxmlformats.org/drawingml/2006/main"/>
           <a:p xmlns:a="http://schemas.openxmlformats.org/drawingml/2006/main">
             <a:pPr algn="l">
+              <a:buNone/>
               <a:defRPr sz="1350" b="0">
                 <a:solidFill>
                   <a:srgbClr val="000000"/>
@@ -3471,6 +3496,7 @@
           <a:lstStyle xmlns:a="http://schemas.openxmlformats.org/drawingml/2006/main"/>
           <a:p xmlns:a="http://schemas.openxmlformats.org/drawingml/2006/main">
             <a:pPr algn="l">
+              <a:buNone/>
               <a:defRPr sz="1125" b="0">
                 <a:solidFill>
                   <a:srgbClr val="555555"/>
@@ -3521,6 +3547,7 @@
           <a:lstStyle xmlns:a="http://schemas.openxmlformats.org/drawingml/2006/main"/>
           <a:p xmlns:a="http://schemas.openxmlformats.org/drawingml/2006/main">
             <a:pPr algn="r">
+              <a:buNone/>
               <a:defRPr sz="1125" b="0">
                 <a:solidFill>
                   <a:srgbClr val="000000"/>
@@ -3600,6 +3627,7 @@
           <a:lstStyle xmlns:a="http://schemas.openxmlformats.org/drawingml/2006/main"/>
           <a:p xmlns:a="http://schemas.openxmlformats.org/drawingml/2006/main">
             <a:pPr algn="l">
+              <a:buNone/>
               <a:defRPr sz="2925" b="0">
                 <a:solidFill>
                   <a:srgbClr val="000000"/>
@@ -3650,6 +3678,7 @@
           <a:lstStyle xmlns:a="http://schemas.openxmlformats.org/drawingml/2006/main"/>
           <a:p xmlns:a="http://schemas.openxmlformats.org/drawingml/2006/main">
             <a:pPr algn="l">
+              <a:buNone/>
               <a:defRPr sz="1650" b="0">
                 <a:solidFill>
                   <a:srgbClr val="555555"/>
@@ -3700,6 +3729,7 @@
           <a:lstStyle xmlns:a="http://schemas.openxmlformats.org/drawingml/2006/main"/>
           <a:p xmlns:a="http://schemas.openxmlformats.org/drawingml/2006/main">
             <a:pPr algn="l">
+              <a:buNone/>
               <a:defRPr sz="1125" b="0">
                 <a:solidFill>
                   <a:srgbClr val="555555"/>
@@ -3750,6 +3780,7 @@
           <a:lstStyle xmlns:a="http://schemas.openxmlformats.org/drawingml/2006/main"/>
           <a:p xmlns:a="http://schemas.openxmlformats.org/drawingml/2006/main">
             <a:pPr algn="r">
+              <a:buNone/>
               <a:defRPr sz="1125" b="0">
                 <a:solidFill>
                   <a:srgbClr val="000000"/>
@@ -3800,6 +3831,7 @@
           <a:lstStyle xmlns:a="http://schemas.openxmlformats.org/drawingml/2006/main"/>
           <a:p xmlns:a="http://schemas.openxmlformats.org/drawingml/2006/main">
             <a:pPr algn="l">
+              <a:buNone/>
               <a:defRPr sz="4200" b="1">
                 <a:solidFill>
                   <a:srgbClr val="FF6B35"/>
@@ -3850,6 +3882,7 @@
           <a:lstStyle xmlns:a="http://schemas.openxmlformats.org/drawingml/2006/main"/>
           <a:p xmlns:a="http://schemas.openxmlformats.org/drawingml/2006/main">
             <a:pPr algn="l">
+              <a:buNone/>
               <a:defRPr sz="2550" b="0">
                 <a:solidFill>
                   <a:srgbClr val="000000"/>
@@ -3931,6 +3964,7 @@
           <a:lstStyle xmlns:a="http://schemas.openxmlformats.org/drawingml/2006/main"/>
           <a:p xmlns:a="http://schemas.openxmlformats.org/drawingml/2006/main">
             <a:pPr algn="ctr">
+              <a:buNone/>
               <a:defRPr sz="2100" b="0">
                 <a:solidFill>
                   <a:srgbClr val="FFFFFF"/>
@@ -4107,6 +4141,7 @@
           <a:lstStyle xmlns:a="http://schemas.openxmlformats.org/drawingml/2006/main"/>
           <a:p xmlns:a="http://schemas.openxmlformats.org/drawingml/2006/main">
             <a:pPr algn="ctr">
+              <a:buNone/>
               <a:defRPr sz="1650" b="0">
                 <a:solidFill>
                   <a:srgbClr val="000000"/>
@@ -4221,6 +4256,7 @@
           <a:lstStyle xmlns:a="http://schemas.openxmlformats.org/drawingml/2006/main"/>
           <a:p xmlns:a="http://schemas.openxmlformats.org/drawingml/2006/main">
             <a:pPr algn="ctr">
+              <a:buNone/>
               <a:defRPr sz="1650" b="0">
                 <a:solidFill>
                   <a:srgbClr val="000000"/>
@@ -4335,6 +4371,7 @@
           <a:lstStyle xmlns:a="http://schemas.openxmlformats.org/drawingml/2006/main"/>
           <a:p xmlns:a="http://schemas.openxmlformats.org/drawingml/2006/main">
             <a:pPr algn="ctr">
+              <a:buNone/>
               <a:defRPr sz="1650" b="0">
                 <a:solidFill>
                   <a:srgbClr val="000000"/>
@@ -4449,6 +4486,7 @@
           <a:lstStyle xmlns:a="http://schemas.openxmlformats.org/drawingml/2006/main"/>
           <a:p xmlns:a="http://schemas.openxmlformats.org/drawingml/2006/main">
             <a:pPr algn="ctr">
+              <a:buNone/>
               <a:defRPr sz="1650" b="0">
                 <a:solidFill>
                   <a:srgbClr val="000000"/>
@@ -4499,6 +4537,7 @@
           <a:lstStyle xmlns:a="http://schemas.openxmlformats.org/drawingml/2006/main"/>
           <a:p xmlns:a="http://schemas.openxmlformats.org/drawingml/2006/main">
             <a:pPr algn="l">
+              <a:buNone/>
               <a:defRPr sz="1800" b="0">
                 <a:solidFill>
                   <a:srgbClr val="000000"/>
@@ -4549,6 +4588,7 @@
           <a:lstStyle xmlns:a="http://schemas.openxmlformats.org/drawingml/2006/main"/>
           <a:p xmlns:a="http://schemas.openxmlformats.org/drawingml/2006/main">
             <a:pPr algn="l">
+              <a:buNone/>
               <a:defRPr sz="1125" b="0">
                 <a:solidFill>
                   <a:srgbClr val="555555"/>
@@ -4599,6 +4639,7 @@
           <a:lstStyle xmlns:a="http://schemas.openxmlformats.org/drawingml/2006/main"/>
           <a:p xmlns:a="http://schemas.openxmlformats.org/drawingml/2006/main">
             <a:pPr algn="r">
+              <a:buNone/>
               <a:defRPr sz="1125" b="0">
                 <a:solidFill>
                   <a:srgbClr val="000000"/>
@@ -4678,6 +4719,7 @@
           <a:lstStyle xmlns:a="http://schemas.openxmlformats.org/drawingml/2006/main"/>
           <a:p xmlns:a="http://schemas.openxmlformats.org/drawingml/2006/main">
             <a:pPr algn="l">
+              <a:buNone/>
               <a:defRPr sz="2925" b="0">
                 <a:solidFill>
                   <a:srgbClr val="000000"/>
@@ -4728,6 +4770,7 @@
           <a:lstStyle xmlns:a="http://schemas.openxmlformats.org/drawingml/2006/main"/>
           <a:p xmlns:a="http://schemas.openxmlformats.org/drawingml/2006/main">
             <a:pPr algn="l">
+              <a:buNone/>
               <a:defRPr sz="1650" b="0">
                 <a:solidFill>
                   <a:srgbClr val="555555"/>
@@ -4778,6 +4821,7 @@
           <a:lstStyle xmlns:a="http://schemas.openxmlformats.org/drawingml/2006/main"/>
           <a:p xmlns:a="http://schemas.openxmlformats.org/drawingml/2006/main">
             <a:pPr algn="l">
+              <a:buNone/>
               <a:defRPr sz="1125" b="0">
                 <a:solidFill>
                   <a:srgbClr val="555555"/>
@@ -4828,6 +4872,7 @@
           <a:lstStyle xmlns:a="http://schemas.openxmlformats.org/drawingml/2006/main"/>
           <a:p xmlns:a="http://schemas.openxmlformats.org/drawingml/2006/main">
             <a:pPr algn="r">
+              <a:buNone/>
               <a:defRPr sz="1125" b="0">
                 <a:solidFill>
                   <a:srgbClr val="000000"/>
@@ -4909,6 +4954,7 @@
           <a:lstStyle xmlns:a="http://schemas.openxmlformats.org/drawingml/2006/main"/>
           <a:p xmlns:a="http://schemas.openxmlformats.org/drawingml/2006/main">
             <a:pPr algn="l">
+              <a:buNone/>
               <a:defRPr sz="1200" b="1">
                 <a:solidFill>
                   <a:srgbClr val="FFFFFF"/>
@@ -4959,6 +5005,7 @@
           <a:lstStyle xmlns:a="http://schemas.openxmlformats.org/drawingml/2006/main"/>
           <a:p xmlns:a="http://schemas.openxmlformats.org/drawingml/2006/main">
             <a:pPr algn="l">
+              <a:buNone/>
               <a:defRPr sz="1350" b="0">
                 <a:solidFill>
                   <a:srgbClr val="FFFFFF"/>
@@ -4976,6 +5023,7 @@
           </a:p>
           <a:p xmlns:a="http://schemas.openxmlformats.org/drawingml/2006/main">
             <a:pPr algn="l">
+              <a:buNone/>
               <a:defRPr sz="1350" b="0">
                 <a:solidFill>
                   <a:srgbClr val="FFFFFF"/>
@@ -4993,6 +5041,7 @@
           </a:p>
           <a:p xmlns:a="http://schemas.openxmlformats.org/drawingml/2006/main">
             <a:pPr algn="l">
+              <a:buNone/>
               <a:defRPr sz="1350" b="0">
                 <a:solidFill>
                   <a:srgbClr val="FFFFFF"/>
@@ -5010,6 +5059,7 @@
           </a:p>
           <a:p xmlns:a="http://schemas.openxmlformats.org/drawingml/2006/main">
             <a:pPr algn="l">
+              <a:buNone/>
               <a:defRPr sz="1350" b="0">
                 <a:solidFill>
                   <a:srgbClr val="FFFFFF"/>
@@ -5027,6 +5077,7 @@
           </a:p>
           <a:p xmlns:a="http://schemas.openxmlformats.org/drawingml/2006/main">
             <a:pPr algn="l">
+              <a:buNone/>
               <a:defRPr sz="1350" b="0">
                 <a:solidFill>
                   <a:srgbClr val="FFFFFF"/>
@@ -5049,6 +5100,7 @@
           </a:p>
           <a:p xmlns:a="http://schemas.openxmlformats.org/drawingml/2006/main">
             <a:pPr algn="l">
+              <a:buNone/>
               <a:defRPr sz="1350" b="0">
                 <a:solidFill>
                   <a:srgbClr val="FFFFFF"/>
@@ -5066,6 +5118,7 @@
           </a:p>
           <a:p xmlns:a="http://schemas.openxmlformats.org/drawingml/2006/main">
             <a:pPr algn="l">
+              <a:buNone/>
               <a:defRPr sz="1350" b="0">
                 <a:solidFill>
                   <a:srgbClr val="FFFFFF"/>
@@ -5147,6 +5200,7 @@
           <a:lstStyle xmlns:a="http://schemas.openxmlformats.org/drawingml/2006/main"/>
           <a:p xmlns:a="http://schemas.openxmlformats.org/drawingml/2006/main">
             <a:pPr algn="l">
+              <a:buNone/>
               <a:defRPr sz="2100" b="0">
                 <a:solidFill>
                   <a:srgbClr val="000000"/>
@@ -5228,6 +5282,7 @@
           <a:lstStyle xmlns:a="http://schemas.openxmlformats.org/drawingml/2006/main"/>
           <a:p xmlns:a="http://schemas.openxmlformats.org/drawingml/2006/main">
             <a:pPr algn="l">
+              <a:buNone/>
               <a:defRPr sz="1650" b="0">
                 <a:solidFill>
                   <a:srgbClr val="222222"/>
@@ -5309,6 +5364,7 @@
           <a:lstStyle xmlns:a="http://schemas.openxmlformats.org/drawingml/2006/main"/>
           <a:p xmlns:a="http://schemas.openxmlformats.org/drawingml/2006/main">
             <a:pPr algn="l">
+              <a:buNone/>
               <a:defRPr sz="1650" b="0">
                 <a:solidFill>
                   <a:srgbClr val="222222"/>
@@ -5390,6 +5446,7 @@
           <a:lstStyle xmlns:a="http://schemas.openxmlformats.org/drawingml/2006/main"/>
           <a:p xmlns:a="http://schemas.openxmlformats.org/drawingml/2006/main">
             <a:pPr algn="l">
+              <a:buNone/>
               <a:defRPr sz="1650" b="0">
                 <a:solidFill>
                   <a:srgbClr val="222222"/>
@@ -5473,6 +5530,7 @@
           <a:lstStyle xmlns:a="http://schemas.openxmlformats.org/drawingml/2006/main"/>
           <a:p xmlns:a="http://schemas.openxmlformats.org/drawingml/2006/main">
             <a:pPr algn="l">
+              <a:buNone/>
               <a:defRPr sz="1350" b="0">
                 <a:solidFill>
                   <a:srgbClr val="000000"/>
@@ -5523,6 +5581,7 @@
           <a:lstStyle xmlns:a="http://schemas.openxmlformats.org/drawingml/2006/main"/>
           <a:p xmlns:a="http://schemas.openxmlformats.org/drawingml/2006/main">
             <a:pPr algn="l">
+              <a:buNone/>
               <a:defRPr sz="1125" b="0">
                 <a:solidFill>
                   <a:srgbClr val="555555"/>
@@ -5573,6 +5632,7 @@
           <a:lstStyle xmlns:a="http://schemas.openxmlformats.org/drawingml/2006/main"/>
           <a:p xmlns:a="http://schemas.openxmlformats.org/drawingml/2006/main">
             <a:pPr algn="r">
+              <a:buNone/>
               <a:defRPr sz="1125" b="0">
                 <a:solidFill>
                   <a:srgbClr val="000000"/>
@@ -5652,6 +5712,7 @@
           <a:lstStyle xmlns:a="http://schemas.openxmlformats.org/drawingml/2006/main"/>
           <a:p xmlns:a="http://schemas.openxmlformats.org/drawingml/2006/main">
             <a:pPr algn="l">
+              <a:buNone/>
               <a:defRPr sz="2925" b="0">
                 <a:solidFill>
                   <a:srgbClr val="000000"/>
@@ -5702,6 +5763,7 @@
           <a:lstStyle xmlns:a="http://schemas.openxmlformats.org/drawingml/2006/main"/>
           <a:p xmlns:a="http://schemas.openxmlformats.org/drawingml/2006/main">
             <a:pPr algn="l">
+              <a:buNone/>
               <a:defRPr sz="1650" b="0">
                 <a:solidFill>
                   <a:srgbClr val="555555"/>
@@ -5752,6 +5814,7 @@
           <a:lstStyle xmlns:a="http://schemas.openxmlformats.org/drawingml/2006/main"/>
           <a:p xmlns:a="http://schemas.openxmlformats.org/drawingml/2006/main">
             <a:pPr algn="l">
+              <a:buNone/>
               <a:defRPr sz="1125" b="0">
                 <a:solidFill>
                   <a:srgbClr val="555555"/>
@@ -5802,6 +5865,7 @@
           <a:lstStyle xmlns:a="http://schemas.openxmlformats.org/drawingml/2006/main"/>
           <a:p xmlns:a="http://schemas.openxmlformats.org/drawingml/2006/main">
             <a:pPr algn="r">
+              <a:buNone/>
               <a:defRPr sz="1125" b="0">
                 <a:solidFill>
                   <a:srgbClr val="000000"/>
@@ -5883,6 +5947,7 @@
           <a:lstStyle xmlns:a="http://schemas.openxmlformats.org/drawingml/2006/main"/>
           <a:p xmlns:a="http://schemas.openxmlformats.org/drawingml/2006/main">
             <a:pPr algn="l">
+              <a:buNone/>
               <a:defRPr sz="1275" b="1">
                 <a:solidFill>
                   <a:srgbClr val="FFFFFF"/>
@@ -5933,6 +5998,7 @@
           <a:lstStyle xmlns:a="http://schemas.openxmlformats.org/drawingml/2006/main"/>
           <a:p xmlns:a="http://schemas.openxmlformats.org/drawingml/2006/main">
             <a:pPr algn="l">
+              <a:buNone/>
               <a:defRPr sz="1275" b="1">
                 <a:solidFill>
                   <a:srgbClr val="FFFFFF"/>
@@ -5983,6 +6049,7 @@
           <a:lstStyle xmlns:a="http://schemas.openxmlformats.org/drawingml/2006/main"/>
           <a:p xmlns:a="http://schemas.openxmlformats.org/drawingml/2006/main">
             <a:pPr algn="l">
+              <a:buNone/>
               <a:defRPr sz="1275" b="1">
                 <a:solidFill>
                   <a:srgbClr val="FFFFFF"/>
@@ -6066,6 +6133,7 @@
           <a:lstStyle xmlns:a="http://schemas.openxmlformats.org/drawingml/2006/main"/>
           <a:p xmlns:a="http://schemas.openxmlformats.org/drawingml/2006/main">
             <a:pPr algn="l">
+              <a:buNone/>
               <a:defRPr sz="1500" b="1">
                 <a:solidFill>
                   <a:srgbClr val="000000"/>
@@ -6116,6 +6184,7 @@
           <a:lstStyle xmlns:a="http://schemas.openxmlformats.org/drawingml/2006/main"/>
           <a:p xmlns:a="http://schemas.openxmlformats.org/drawingml/2006/main">
             <a:pPr algn="l">
+              <a:buNone/>
               <a:defRPr sz="1500" b="0">
                 <a:solidFill>
                   <a:srgbClr val="222222"/>
@@ -6166,6 +6235,7 @@
           <a:lstStyle xmlns:a="http://schemas.openxmlformats.org/drawingml/2006/main"/>
           <a:p xmlns:a="http://schemas.openxmlformats.org/drawingml/2006/main">
             <a:pPr algn="l">
+              <a:buNone/>
               <a:defRPr sz="1500" b="0">
                 <a:solidFill>
                   <a:srgbClr val="222222"/>
@@ -6249,6 +6319,7 @@
           <a:lstStyle xmlns:a="http://schemas.openxmlformats.org/drawingml/2006/main"/>
           <a:p xmlns:a="http://schemas.openxmlformats.org/drawingml/2006/main">
             <a:pPr algn="l">
+              <a:buNone/>
               <a:defRPr sz="1500" b="1">
                 <a:solidFill>
                   <a:srgbClr val="000000"/>
@@ -6299,6 +6370,7 @@
           <a:lstStyle xmlns:a="http://schemas.openxmlformats.org/drawingml/2006/main"/>
           <a:p xmlns:a="http://schemas.openxmlformats.org/drawingml/2006/main">
             <a:pPr algn="l">
+              <a:buNone/>
               <a:defRPr sz="1500" b="0">
                 <a:solidFill>
                   <a:srgbClr val="222222"/>
@@ -6349,6 +6421,7 @@
           <a:lstStyle xmlns:a="http://schemas.openxmlformats.org/drawingml/2006/main"/>
           <a:p xmlns:a="http://schemas.openxmlformats.org/drawingml/2006/main">
             <a:pPr algn="l">
+              <a:buNone/>
               <a:defRPr sz="1500" b="0">
                 <a:solidFill>
                   <a:srgbClr val="222222"/>
@@ -6432,6 +6505,7 @@
           <a:lstStyle xmlns:a="http://schemas.openxmlformats.org/drawingml/2006/main"/>
           <a:p xmlns:a="http://schemas.openxmlformats.org/drawingml/2006/main">
             <a:pPr algn="l">
+              <a:buNone/>
               <a:defRPr sz="1500" b="1">
                 <a:solidFill>
                   <a:srgbClr val="000000"/>
@@ -6482,6 +6556,7 @@
           <a:lstStyle xmlns:a="http://schemas.openxmlformats.org/drawingml/2006/main"/>
           <a:p xmlns:a="http://schemas.openxmlformats.org/drawingml/2006/main">
             <a:pPr algn="l">
+              <a:buNone/>
               <a:defRPr sz="1500" b="0">
                 <a:solidFill>
                   <a:srgbClr val="222222"/>
@@ -6532,6 +6607,7 @@
           <a:lstStyle xmlns:a="http://schemas.openxmlformats.org/drawingml/2006/main"/>
           <a:p xmlns:a="http://schemas.openxmlformats.org/drawingml/2006/main">
             <a:pPr algn="l">
+              <a:buNone/>
               <a:defRPr sz="1500" b="0">
                 <a:solidFill>
                   <a:srgbClr val="222222"/>
@@ -6615,6 +6691,7 @@
           <a:lstStyle xmlns:a="http://schemas.openxmlformats.org/drawingml/2006/main"/>
           <a:p xmlns:a="http://schemas.openxmlformats.org/drawingml/2006/main">
             <a:pPr algn="l">
+              <a:buNone/>
               <a:defRPr sz="1500" b="1">
                 <a:solidFill>
                   <a:srgbClr val="000000"/>
@@ -6665,6 +6742,7 @@
           <a:lstStyle xmlns:a="http://schemas.openxmlformats.org/drawingml/2006/main"/>
           <a:p xmlns:a="http://schemas.openxmlformats.org/drawingml/2006/main">
             <a:pPr algn="l">
+              <a:buNone/>
               <a:defRPr sz="1500" b="0">
                 <a:solidFill>
                   <a:srgbClr val="222222"/>
@@ -6715,6 +6793,7 @@
           <a:lstStyle xmlns:a="http://schemas.openxmlformats.org/drawingml/2006/main"/>
           <a:p xmlns:a="http://schemas.openxmlformats.org/drawingml/2006/main">
             <a:pPr algn="l">
+              <a:buNone/>
               <a:defRPr sz="1500" b="0">
                 <a:solidFill>
                   <a:srgbClr val="222222"/>
@@ -6798,6 +6877,7 @@
           <a:lstStyle xmlns:a="http://schemas.openxmlformats.org/drawingml/2006/main"/>
           <a:p xmlns:a="http://schemas.openxmlformats.org/drawingml/2006/main">
             <a:pPr algn="l">
+              <a:buNone/>
               <a:defRPr sz="1500" b="1">
                 <a:solidFill>
                   <a:srgbClr val="000000"/>
@@ -6848,6 +6928,7 @@
           <a:lstStyle xmlns:a="http://schemas.openxmlformats.org/drawingml/2006/main"/>
           <a:p xmlns:a="http://schemas.openxmlformats.org/drawingml/2006/main">
             <a:pPr algn="l">
+              <a:buNone/>
               <a:defRPr sz="1500" b="0">
                 <a:solidFill>
                   <a:srgbClr val="222222"/>
@@ -6898,6 +6979,7 @@
           <a:lstStyle xmlns:a="http://schemas.openxmlformats.org/drawingml/2006/main"/>
           <a:p xmlns:a="http://schemas.openxmlformats.org/drawingml/2006/main">
             <a:pPr algn="l">
+              <a:buNone/>
               <a:defRPr sz="1500" b="0">
                 <a:solidFill>
                   <a:srgbClr val="222222"/>
@@ -6948,6 +7030,7 @@
           <a:lstStyle xmlns:a="http://schemas.openxmlformats.org/drawingml/2006/main"/>
           <a:p xmlns:a="http://schemas.openxmlformats.org/drawingml/2006/main">
             <a:pPr algn="l">
+              <a:buNone/>
               <a:defRPr sz="1350" b="1">
                 <a:solidFill>
                   <a:srgbClr val="000000"/>
@@ -6998,6 +7081,7 @@
           <a:lstStyle xmlns:a="http://schemas.openxmlformats.org/drawingml/2006/main"/>
           <a:p xmlns:a="http://schemas.openxmlformats.org/drawingml/2006/main">
             <a:pPr algn="l">
+              <a:buNone/>
               <a:defRPr sz="1350" b="1">
                 <a:solidFill>
                   <a:srgbClr val="000000"/>
@@ -7048,6 +7132,7 @@
           <a:lstStyle xmlns:a="http://schemas.openxmlformats.org/drawingml/2006/main"/>
           <a:p xmlns:a="http://schemas.openxmlformats.org/drawingml/2006/main">
             <a:pPr algn="l">
+              <a:buNone/>
               <a:defRPr sz="1200" b="0">
                 <a:solidFill>
                   <a:srgbClr val="555555"/>
@@ -7098,6 +7183,7 @@
           <a:lstStyle xmlns:a="http://schemas.openxmlformats.org/drawingml/2006/main"/>
           <a:p xmlns:a="http://schemas.openxmlformats.org/drawingml/2006/main">
             <a:pPr algn="l">
+              <a:buNone/>
               <a:defRPr sz="1350" b="1">
                 <a:solidFill>
                   <a:srgbClr val="000000"/>
@@ -7148,6 +7234,7 @@
           <a:lstStyle xmlns:a="http://schemas.openxmlformats.org/drawingml/2006/main"/>
           <a:p xmlns:a="http://schemas.openxmlformats.org/drawingml/2006/main">
             <a:pPr algn="l">
+              <a:buNone/>
               <a:defRPr sz="1200" b="0">
                 <a:solidFill>
                   <a:srgbClr val="555555"/>
@@ -7198,6 +7285,7 @@
           <a:lstStyle xmlns:a="http://schemas.openxmlformats.org/drawingml/2006/main"/>
           <a:p xmlns:a="http://schemas.openxmlformats.org/drawingml/2006/main">
             <a:pPr algn="l">
+              <a:buNone/>
               <a:defRPr sz="1125" b="0">
                 <a:solidFill>
                   <a:srgbClr val="555555"/>
@@ -7248,6 +7336,7 @@
           <a:lstStyle xmlns:a="http://schemas.openxmlformats.org/drawingml/2006/main"/>
           <a:p xmlns:a="http://schemas.openxmlformats.org/drawingml/2006/main">
             <a:pPr algn="r">
+              <a:buNone/>
               <a:defRPr sz="1125" b="0">
                 <a:solidFill>
                   <a:srgbClr val="000000"/>
@@ -7327,6 +7416,7 @@
           <a:lstStyle xmlns:a="http://schemas.openxmlformats.org/drawingml/2006/main"/>
           <a:p xmlns:a="http://schemas.openxmlformats.org/drawingml/2006/main">
             <a:pPr algn="l">
+              <a:buNone/>
               <a:defRPr sz="2925" b="0">
                 <a:solidFill>
                   <a:srgbClr val="000000"/>
@@ -7377,6 +7467,7 @@
           <a:lstStyle xmlns:a="http://schemas.openxmlformats.org/drawingml/2006/main"/>
           <a:p xmlns:a="http://schemas.openxmlformats.org/drawingml/2006/main">
             <a:pPr algn="l">
+              <a:buNone/>
               <a:defRPr sz="1650" b="0">
                 <a:solidFill>
                   <a:srgbClr val="555555"/>
@@ -7427,6 +7518,7 @@
           <a:lstStyle xmlns:a="http://schemas.openxmlformats.org/drawingml/2006/main"/>
           <a:p xmlns:a="http://schemas.openxmlformats.org/drawingml/2006/main">
             <a:pPr algn="l">
+              <a:buNone/>
               <a:defRPr sz="1125" b="0">
                 <a:solidFill>
                   <a:srgbClr val="555555"/>
@@ -7477,6 +7569,7 @@
           <a:lstStyle xmlns:a="http://schemas.openxmlformats.org/drawingml/2006/main"/>
           <a:p xmlns:a="http://schemas.openxmlformats.org/drawingml/2006/main">
             <a:pPr algn="r">
+              <a:buNone/>
               <a:defRPr sz="1125" b="0">
                 <a:solidFill>
                   <a:srgbClr val="000000"/>
@@ -7560,6 +7653,7 @@
           <a:lstStyle xmlns:a="http://schemas.openxmlformats.org/drawingml/2006/main"/>
           <a:p xmlns:a="http://schemas.openxmlformats.org/drawingml/2006/main">
             <a:pPr algn="l">
+              <a:buNone/>
               <a:defRPr sz="1200" b="1">
                 <a:solidFill>
                   <a:srgbClr val="555555"/>
@@ -7610,6 +7704,7 @@
           <a:lstStyle xmlns:a="http://schemas.openxmlformats.org/drawingml/2006/main"/>
           <a:p xmlns:a="http://schemas.openxmlformats.org/drawingml/2006/main">
             <a:pPr algn="l">
+              <a:buNone/>
               <a:defRPr sz="1950" b="0">
                 <a:solidFill>
                   <a:srgbClr val="000000"/>
@@ -7660,6 +7755,7 @@
           <a:lstStyle xmlns:a="http://schemas.openxmlformats.org/drawingml/2006/main"/>
           <a:p xmlns:a="http://schemas.openxmlformats.org/drawingml/2006/main">
             <a:pPr algn="l">
+              <a:buNone/>
               <a:defRPr sz="1350" b="0">
                 <a:solidFill>
                   <a:srgbClr val="222222"/>
@@ -7774,6 +7870,7 @@
           <a:lstStyle xmlns:a="http://schemas.openxmlformats.org/drawingml/2006/main"/>
           <a:p xmlns:a="http://schemas.openxmlformats.org/drawingml/2006/main">
             <a:pPr algn="l">
+              <a:buNone/>
               <a:defRPr sz="1200" b="1">
                 <a:solidFill>
                   <a:srgbClr val="555555"/>
@@ -7824,6 +7921,7 @@
           <a:lstStyle xmlns:a="http://schemas.openxmlformats.org/drawingml/2006/main"/>
           <a:p xmlns:a="http://schemas.openxmlformats.org/drawingml/2006/main">
             <a:pPr algn="l">
+              <a:buNone/>
               <a:defRPr sz="1950" b="0">
                 <a:solidFill>
                   <a:srgbClr val="000000"/>
@@ -7874,6 +7972,7 @@
           <a:lstStyle xmlns:a="http://schemas.openxmlformats.org/drawingml/2006/main"/>
           <a:p xmlns:a="http://schemas.openxmlformats.org/drawingml/2006/main">
             <a:pPr algn="l">
+              <a:buNone/>
               <a:defRPr sz="1350" b="0">
                 <a:solidFill>
                   <a:srgbClr val="222222"/>
@@ -7988,6 +8087,7 @@
           <a:lstStyle xmlns:a="http://schemas.openxmlformats.org/drawingml/2006/main"/>
           <a:p xmlns:a="http://schemas.openxmlformats.org/drawingml/2006/main">
             <a:pPr algn="l">
+              <a:buNone/>
               <a:defRPr sz="1200" b="1">
                 <a:solidFill>
                   <a:srgbClr val="555555"/>
@@ -8038,6 +8138,7 @@
           <a:lstStyle xmlns:a="http://schemas.openxmlformats.org/drawingml/2006/main"/>
           <a:p xmlns:a="http://schemas.openxmlformats.org/drawingml/2006/main">
             <a:pPr algn="l">
+              <a:buNone/>
               <a:defRPr sz="1950" b="0">
                 <a:solidFill>
                   <a:srgbClr val="000000"/>
@@ -8088,6 +8189,7 @@
           <a:lstStyle xmlns:a="http://schemas.openxmlformats.org/drawingml/2006/main"/>
           <a:p xmlns:a="http://schemas.openxmlformats.org/drawingml/2006/main">
             <a:pPr algn="l">
+              <a:buNone/>
               <a:defRPr sz="1350" b="0">
                 <a:solidFill>
                   <a:srgbClr val="222222"/>
@@ -8138,6 +8240,7 @@
           <a:lstStyle xmlns:a="http://schemas.openxmlformats.org/drawingml/2006/main"/>
           <a:p xmlns:a="http://schemas.openxmlformats.org/drawingml/2006/main">
             <a:pPr algn="l">
+              <a:buNone/>
               <a:defRPr sz="1875" b="0">
                 <a:solidFill>
                   <a:srgbClr val="000000"/>
@@ -8217,6 +8320,7 @@
           <a:lstStyle xmlns:a="http://schemas.openxmlformats.org/drawingml/2006/main"/>
           <a:p xmlns:a="http://schemas.openxmlformats.org/drawingml/2006/main">
             <a:pPr algn="l">
+              <a:buNone/>
               <a:defRPr sz="2925" b="0">
                 <a:solidFill>
                   <a:srgbClr val="000000"/>
@@ -8267,6 +8371,7 @@
           <a:lstStyle xmlns:a="http://schemas.openxmlformats.org/drawingml/2006/main"/>
           <a:p xmlns:a="http://schemas.openxmlformats.org/drawingml/2006/main">
             <a:pPr algn="l">
+              <a:buNone/>
               <a:defRPr sz="1650" b="0">
                 <a:solidFill>
                   <a:srgbClr val="555555"/>
@@ -8317,6 +8422,7 @@
           <a:lstStyle xmlns:a="http://schemas.openxmlformats.org/drawingml/2006/main"/>
           <a:p xmlns:a="http://schemas.openxmlformats.org/drawingml/2006/main">
             <a:pPr algn="l">
+              <a:buNone/>
               <a:defRPr sz="1125" b="0">
                 <a:solidFill>
                   <a:srgbClr val="555555"/>
@@ -8367,6 +8473,7 @@
           <a:lstStyle xmlns:a="http://schemas.openxmlformats.org/drawingml/2006/main"/>
           <a:p xmlns:a="http://schemas.openxmlformats.org/drawingml/2006/main">
             <a:pPr algn="r">
+              <a:buNone/>
               <a:defRPr sz="1125" b="0">
                 <a:solidFill>
                   <a:srgbClr val="000000"/>
@@ -8417,6 +8524,7 @@
           <a:lstStyle xmlns:a="http://schemas.openxmlformats.org/drawingml/2006/main"/>
           <a:p xmlns:a="http://schemas.openxmlformats.org/drawingml/2006/main">
             <a:pPr algn="l">
+              <a:buNone/>
               <a:defRPr sz="4200" b="1">
                 <a:solidFill>
                   <a:srgbClr val="FF6B35"/>
@@ -8467,6 +8575,7 @@
           <a:lstStyle xmlns:a="http://schemas.openxmlformats.org/drawingml/2006/main"/>
           <a:p xmlns:a="http://schemas.openxmlformats.org/drawingml/2006/main">
             <a:pPr algn="l">
+              <a:buNone/>
               <a:defRPr sz="2550" b="0">
                 <a:solidFill>
                   <a:srgbClr val="000000"/>
@@ -8548,6 +8657,7 @@
           <a:lstStyle xmlns:a="http://schemas.openxmlformats.org/drawingml/2006/main"/>
           <a:p xmlns:a="http://schemas.openxmlformats.org/drawingml/2006/main">
             <a:pPr algn="l">
+              <a:buNone/>
               <a:defRPr sz="1650" b="0">
                 <a:solidFill>
                   <a:srgbClr val="222222"/>
@@ -8629,6 +8739,7 @@
           <a:lstStyle xmlns:a="http://schemas.openxmlformats.org/drawingml/2006/main"/>
           <a:p xmlns:a="http://schemas.openxmlformats.org/drawingml/2006/main">
             <a:pPr algn="l">
+              <a:buNone/>
               <a:defRPr sz="1650" b="0">
                 <a:solidFill>
                   <a:srgbClr val="222222"/>
@@ -8710,6 +8821,7 @@
           <a:lstStyle xmlns:a="http://schemas.openxmlformats.org/drawingml/2006/main"/>
           <a:p xmlns:a="http://schemas.openxmlformats.org/drawingml/2006/main">
             <a:pPr algn="l">
+              <a:buNone/>
               <a:defRPr sz="1650" b="0">
                 <a:solidFill>
                   <a:srgbClr val="222222"/>
@@ -8793,6 +8905,7 @@
           <a:lstStyle xmlns:a="http://schemas.openxmlformats.org/drawingml/2006/main"/>
           <a:p xmlns:a="http://schemas.openxmlformats.org/drawingml/2006/main">
             <a:pPr algn="l">
+              <a:buNone/>
               <a:defRPr sz="1350" b="0">
                 <a:solidFill>
                   <a:srgbClr val="000000"/>
@@ -8872,6 +8985,7 @@
           <a:lstStyle xmlns:a="http://schemas.openxmlformats.org/drawingml/2006/main"/>
           <a:p xmlns:a="http://schemas.openxmlformats.org/drawingml/2006/main">
             <a:pPr algn="l">
+              <a:buNone/>
               <a:defRPr sz="2925" b="0">
                 <a:solidFill>
                   <a:srgbClr val="000000"/>
@@ -8922,6 +9036,7 @@
           <a:lstStyle xmlns:a="http://schemas.openxmlformats.org/drawingml/2006/main"/>
           <a:p xmlns:a="http://schemas.openxmlformats.org/drawingml/2006/main">
             <a:pPr algn="l">
+              <a:buNone/>
               <a:defRPr sz="1650" b="0">
                 <a:solidFill>
                   <a:srgbClr val="555555"/>
@@ -8972,6 +9087,7 @@
           <a:lstStyle xmlns:a="http://schemas.openxmlformats.org/drawingml/2006/main"/>
           <a:p xmlns:a="http://schemas.openxmlformats.org/drawingml/2006/main">
             <a:pPr algn="l">
+              <a:buNone/>
               <a:defRPr sz="1125" b="0">
                 <a:solidFill>
                   <a:srgbClr val="555555"/>
@@ -9022,6 +9138,7 @@
           <a:lstStyle xmlns:a="http://schemas.openxmlformats.org/drawingml/2006/main"/>
           <a:p xmlns:a="http://schemas.openxmlformats.org/drawingml/2006/main">
             <a:pPr algn="r">
+              <a:buNone/>
               <a:defRPr sz="1125" b="0">
                 <a:solidFill>
                   <a:srgbClr val="000000"/>
@@ -9103,6 +9220,7 @@
           <a:lstStyle xmlns:a="http://schemas.openxmlformats.org/drawingml/2006/main"/>
           <a:p xmlns:a="http://schemas.openxmlformats.org/drawingml/2006/main">
             <a:pPr algn="l">
+              <a:buNone/>
               <a:defRPr sz="1200" b="1">
                 <a:solidFill>
                   <a:srgbClr val="FFFFFF"/>
@@ -9153,6 +9271,7 @@
           <a:lstStyle xmlns:a="http://schemas.openxmlformats.org/drawingml/2006/main"/>
           <a:p xmlns:a="http://schemas.openxmlformats.org/drawingml/2006/main">
             <a:pPr algn="l">
+              <a:buNone/>
               <a:defRPr sz="1350" b="0">
                 <a:solidFill>
                   <a:srgbClr val="FFFFFF"/>
@@ -9170,6 +9289,7 @@
           </a:p>
           <a:p xmlns:a="http://schemas.openxmlformats.org/drawingml/2006/main">
             <a:pPr algn="l">
+              <a:buNone/>
               <a:defRPr sz="1350" b="0">
                 <a:solidFill>
                   <a:srgbClr val="FFFFFF"/>
@@ -9187,6 +9307,7 @@
           </a:p>
           <a:p xmlns:a="http://schemas.openxmlformats.org/drawingml/2006/main">
             <a:pPr algn="l">
+              <a:buNone/>
               <a:defRPr sz="1350" b="0">
                 <a:solidFill>
                   <a:srgbClr val="FFFFFF"/>
@@ -9204,6 +9325,7 @@
           </a:p>
           <a:p xmlns:a="http://schemas.openxmlformats.org/drawingml/2006/main">
             <a:pPr algn="l">
+              <a:buNone/>
               <a:defRPr sz="1350" b="0">
                 <a:solidFill>
                   <a:srgbClr val="FFFFFF"/>
@@ -9221,6 +9343,7 @@
           </a:p>
           <a:p xmlns:a="http://schemas.openxmlformats.org/drawingml/2006/main">
             <a:pPr algn="l">
+              <a:buNone/>
               <a:defRPr sz="1350" b="0">
                 <a:solidFill>
                   <a:srgbClr val="FFFFFF"/>
@@ -9238,6 +9361,7 @@
           </a:p>
           <a:p xmlns:a="http://schemas.openxmlformats.org/drawingml/2006/main">
             <a:pPr algn="l">
+              <a:buNone/>
               <a:defRPr sz="1350" b="0">
                 <a:solidFill>
                   <a:srgbClr val="FFFFFF"/>
@@ -9255,6 +9379,7 @@
           </a:p>
           <a:p xmlns:a="http://schemas.openxmlformats.org/drawingml/2006/main">
             <a:pPr algn="l">
+              <a:buNone/>
               <a:defRPr sz="1350" b="0">
                 <a:solidFill>
                   <a:srgbClr val="FFFFFF"/>
@@ -9272,6 +9397,7 @@
           </a:p>
           <a:p xmlns:a="http://schemas.openxmlformats.org/drawingml/2006/main">
             <a:pPr algn="l">
+              <a:buNone/>
               <a:defRPr sz="1350" b="0">
                 <a:solidFill>
                   <a:srgbClr val="FFFFFF"/>
@@ -9353,6 +9479,7 @@
           <a:lstStyle xmlns:a="http://schemas.openxmlformats.org/drawingml/2006/main"/>
           <a:p xmlns:a="http://schemas.openxmlformats.org/drawingml/2006/main">
             <a:pPr algn="l">
+              <a:buNone/>
               <a:defRPr sz="2100" b="0">
                 <a:solidFill>
                   <a:srgbClr val="000000"/>
@@ -9434,6 +9561,7 @@
           <a:lstStyle xmlns:a="http://schemas.openxmlformats.org/drawingml/2006/main"/>
           <a:p xmlns:a="http://schemas.openxmlformats.org/drawingml/2006/main">
             <a:pPr algn="l">
+              <a:buNone/>
               <a:defRPr sz="1650" b="0">
                 <a:solidFill>
                   <a:srgbClr val="222222"/>
@@ -9515,6 +9643,7 @@
           <a:lstStyle xmlns:a="http://schemas.openxmlformats.org/drawingml/2006/main"/>
           <a:p xmlns:a="http://schemas.openxmlformats.org/drawingml/2006/main">
             <a:pPr algn="l">
+              <a:buNone/>
               <a:defRPr sz="1650" b="0">
                 <a:solidFill>
                   <a:srgbClr val="222222"/>
@@ -9596,6 +9725,7 @@
           <a:lstStyle xmlns:a="http://schemas.openxmlformats.org/drawingml/2006/main"/>
           <a:p xmlns:a="http://schemas.openxmlformats.org/drawingml/2006/main">
             <a:pPr algn="l">
+              <a:buNone/>
               <a:defRPr sz="1650" b="0">
                 <a:solidFill>
                   <a:srgbClr val="222222"/>
@@ -9646,6 +9776,7 @@
           <a:lstStyle xmlns:a="http://schemas.openxmlformats.org/drawingml/2006/main"/>
           <a:p xmlns:a="http://schemas.openxmlformats.org/drawingml/2006/main">
             <a:pPr algn="l">
+              <a:buNone/>
               <a:defRPr sz="1125" b="0">
                 <a:solidFill>
                   <a:srgbClr val="555555"/>
@@ -9696,6 +9827,7 @@
           <a:lstStyle xmlns:a="http://schemas.openxmlformats.org/drawingml/2006/main"/>
           <a:p xmlns:a="http://schemas.openxmlformats.org/drawingml/2006/main">
             <a:pPr algn="r">
+              <a:buNone/>
               <a:defRPr sz="1125" b="0">
                 <a:solidFill>
                   <a:srgbClr val="000000"/>
@@ -9775,6 +9907,7 @@
           <a:lstStyle xmlns:a="http://schemas.openxmlformats.org/drawingml/2006/main"/>
           <a:p xmlns:a="http://schemas.openxmlformats.org/drawingml/2006/main">
             <a:pPr algn="l">
+              <a:buNone/>
               <a:defRPr sz="2925" b="0">
                 <a:solidFill>
                   <a:srgbClr val="000000"/>
@@ -9825,6 +9958,7 @@
           <a:lstStyle xmlns:a="http://schemas.openxmlformats.org/drawingml/2006/main"/>
           <a:p xmlns:a="http://schemas.openxmlformats.org/drawingml/2006/main">
             <a:pPr algn="l">
+              <a:buNone/>
               <a:defRPr sz="1650" b="0">
                 <a:solidFill>
                   <a:srgbClr val="555555"/>
@@ -9875,6 +10009,7 @@
           <a:lstStyle xmlns:a="http://schemas.openxmlformats.org/drawingml/2006/main"/>
           <a:p xmlns:a="http://schemas.openxmlformats.org/drawingml/2006/main">
             <a:pPr algn="l">
+              <a:buNone/>
               <a:defRPr sz="1125" b="0">
                 <a:solidFill>
                   <a:srgbClr val="555555"/>
@@ -9925,6 +10060,7 @@
           <a:lstStyle xmlns:a="http://schemas.openxmlformats.org/drawingml/2006/main"/>
           <a:p xmlns:a="http://schemas.openxmlformats.org/drawingml/2006/main">
             <a:pPr algn="r">
+              <a:buNone/>
               <a:defRPr sz="1125" b="0">
                 <a:solidFill>
                   <a:srgbClr val="000000"/>
@@ -9975,6 +10111,7 @@
           <a:lstStyle xmlns:a="http://schemas.openxmlformats.org/drawingml/2006/main"/>
           <a:p xmlns:a="http://schemas.openxmlformats.org/drawingml/2006/main">
             <a:pPr algn="l">
+              <a:buNone/>
               <a:defRPr sz="4200" b="1">
                 <a:solidFill>
                   <a:srgbClr val="FF6B35"/>
@@ -10025,6 +10162,7 @@
           <a:lstStyle xmlns:a="http://schemas.openxmlformats.org/drawingml/2006/main"/>
           <a:p xmlns:a="http://schemas.openxmlformats.org/drawingml/2006/main">
             <a:pPr algn="l">
+              <a:buNone/>
               <a:defRPr sz="2550" b="0">
                 <a:solidFill>
                   <a:srgbClr val="000000"/>
@@ -10106,6 +10244,7 @@
           <a:lstStyle xmlns:a="http://schemas.openxmlformats.org/drawingml/2006/main"/>
           <a:p xmlns:a="http://schemas.openxmlformats.org/drawingml/2006/main">
             <a:pPr algn="l">
+              <a:buNone/>
               <a:defRPr sz="2250" b="0">
                 <a:solidFill>
                   <a:srgbClr val="000000"/>
@@ -10156,6 +10295,7 @@
           <a:lstStyle xmlns:a="http://schemas.openxmlformats.org/drawingml/2006/main"/>
           <a:p xmlns:a="http://schemas.openxmlformats.org/drawingml/2006/main">
             <a:pPr algn="l">
+              <a:buNone/>
               <a:defRPr sz="1575" b="0">
                 <a:solidFill>
                   <a:srgbClr val="222222"/>
@@ -10173,6 +10313,7 @@
           </a:p>
           <a:p xmlns:a="http://schemas.openxmlformats.org/drawingml/2006/main">
             <a:pPr algn="l">
+              <a:buNone/>
               <a:defRPr sz="1575" b="0">
                 <a:solidFill>
                   <a:srgbClr val="222222"/>
@@ -10190,6 +10331,7 @@
           </a:p>
           <a:p xmlns:a="http://schemas.openxmlformats.org/drawingml/2006/main">
             <a:pPr algn="l">
+              <a:buNone/>
               <a:defRPr sz="1575" b="0">
                 <a:solidFill>
                   <a:srgbClr val="222222"/>
@@ -10273,6 +10415,7 @@
           <a:lstStyle xmlns:a="http://schemas.openxmlformats.org/drawingml/2006/main"/>
           <a:p xmlns:a="http://schemas.openxmlformats.org/drawingml/2006/main">
             <a:pPr algn="l">
+              <a:buNone/>
               <a:defRPr sz="2250" b="0">
                 <a:solidFill>
                   <a:srgbClr val="000000"/>
@@ -10323,6 +10466,7 @@
           <a:lstStyle xmlns:a="http://schemas.openxmlformats.org/drawingml/2006/main"/>
           <a:p xmlns:a="http://schemas.openxmlformats.org/drawingml/2006/main">
             <a:pPr algn="l">
+              <a:buNone/>
               <a:defRPr sz="1575" b="0">
                 <a:solidFill>
                   <a:srgbClr val="222222"/>
@@ -10340,6 +10484,7 @@
           </a:p>
           <a:p xmlns:a="http://schemas.openxmlformats.org/drawingml/2006/main">
             <a:pPr algn="l">
+              <a:buNone/>
               <a:defRPr sz="1575" b="0">
                 <a:solidFill>
                   <a:srgbClr val="222222"/>
@@ -10357,6 +10502,7 @@
           </a:p>
           <a:p xmlns:a="http://schemas.openxmlformats.org/drawingml/2006/main">
             <a:pPr algn="l">
+              <a:buNone/>
               <a:defRPr sz="1575" b="0">
                 <a:solidFill>
                   <a:srgbClr val="222222"/>
@@ -10438,6 +10584,7 @@
           <a:lstStyle xmlns:a="http://schemas.openxmlformats.org/drawingml/2006/main"/>
           <a:p xmlns:a="http://schemas.openxmlformats.org/drawingml/2006/main">
             <a:pPr algn="l">
+              <a:buNone/>
               <a:defRPr sz="1800" b="0">
                 <a:solidFill>
                   <a:srgbClr val="000000"/>
@@ -10488,6 +10635,7 @@
           <a:lstStyle xmlns:a="http://schemas.openxmlformats.org/drawingml/2006/main"/>
           <a:p xmlns:a="http://schemas.openxmlformats.org/drawingml/2006/main">
             <a:pPr algn="l">
+              <a:buNone/>
               <a:defRPr sz="1125" b="0">
                 <a:solidFill>
                   <a:srgbClr val="555555"/>
@@ -10538,6 +10686,7 @@
           <a:lstStyle xmlns:a="http://schemas.openxmlformats.org/drawingml/2006/main"/>
           <a:p xmlns:a="http://schemas.openxmlformats.org/drawingml/2006/main">
             <a:pPr algn="r">
+              <a:buNone/>
               <a:defRPr sz="1125" b="0">
                 <a:solidFill>
                   <a:srgbClr val="000000"/>
@@ -10617,6 +10766,7 @@
           <a:lstStyle xmlns:a="http://schemas.openxmlformats.org/drawingml/2006/main"/>
           <a:p xmlns:a="http://schemas.openxmlformats.org/drawingml/2006/main">
             <a:pPr algn="l">
+              <a:buNone/>
               <a:defRPr sz="2925" b="0">
                 <a:solidFill>
                   <a:srgbClr val="000000"/>
@@ -10667,6 +10817,7 @@
           <a:lstStyle xmlns:a="http://schemas.openxmlformats.org/drawingml/2006/main"/>
           <a:p xmlns:a="http://schemas.openxmlformats.org/drawingml/2006/main">
             <a:pPr algn="l">
+              <a:buNone/>
               <a:defRPr sz="1650" b="0">
                 <a:solidFill>
                   <a:srgbClr val="555555"/>
@@ -10717,6 +10868,7 @@
           <a:lstStyle xmlns:a="http://schemas.openxmlformats.org/drawingml/2006/main"/>
           <a:p xmlns:a="http://schemas.openxmlformats.org/drawingml/2006/main">
             <a:pPr algn="l">
+              <a:buNone/>
               <a:defRPr sz="1125" b="0">
                 <a:solidFill>
                   <a:srgbClr val="555555"/>
@@ -10767,6 +10919,7 @@
           <a:lstStyle xmlns:a="http://schemas.openxmlformats.org/drawingml/2006/main"/>
           <a:p xmlns:a="http://schemas.openxmlformats.org/drawingml/2006/main">
             <a:pPr algn="r">
+              <a:buNone/>
               <a:defRPr sz="1125" b="0">
                 <a:solidFill>
                   <a:srgbClr val="000000"/>
@@ -10848,6 +11001,7 @@
           <a:lstStyle xmlns:a="http://schemas.openxmlformats.org/drawingml/2006/main"/>
           <a:p xmlns:a="http://schemas.openxmlformats.org/drawingml/2006/main">
             <a:pPr algn="l">
+              <a:buNone/>
               <a:defRPr sz="1200" b="1">
                 <a:solidFill>
                   <a:srgbClr val="FFFFFF"/>
@@ -10898,6 +11052,7 @@
           <a:lstStyle xmlns:a="http://schemas.openxmlformats.org/drawingml/2006/main"/>
           <a:p xmlns:a="http://schemas.openxmlformats.org/drawingml/2006/main">
             <a:pPr algn="l">
+              <a:buNone/>
               <a:defRPr sz="1350" b="0">
                 <a:solidFill>
                   <a:srgbClr val="FFFFFF"/>
@@ -10910,11 +11065,12 @@
                   <a:srgbClr val="FFFFFF"/>
                 </a:solidFill>
               </a:rPr>
-              <a:t>def score(task, skill):</a:t>
-            </a:r>
-          </a:p>
-          <a:p xmlns:a="http://schemas.openxmlformats.org/drawingml/2006/main">
-            <a:pPr algn="l">
+              <a:t>def score(task: str, skill: Skill) -&gt; int:</a:t>
+            </a:r>
+          </a:p>
+          <a:p xmlns:a="http://schemas.openxmlformats.org/drawingml/2006/main">
+            <a:pPr algn="l">
+              <a:buNone/>
               <a:defRPr sz="1350" b="0">
                 <a:solidFill>
                   <a:srgbClr val="FFFFFF"/>
@@ -10927,11 +11083,12 @@
                   <a:srgbClr val="FFFFFF"/>
                 </a:solidFill>
               </a:rPr>
-              <a:t>    haystack = f"{skill.name} {skill.description}".lower()</a:t>
-            </a:r>
-          </a:p>
-          <a:p xmlns:a="http://schemas.openxmlformats.org/drawingml/2006/main">
-            <a:pPr algn="l">
+              <a:t>    haystack = tokenize(</a:t>
+            </a:r>
+          </a:p>
+          <a:p xmlns:a="http://schemas.openxmlformats.org/drawingml/2006/main">
+            <a:pPr algn="l">
+              <a:buNone/>
               <a:defRPr sz="1350" b="0">
                 <a:solidFill>
                   <a:srgbClr val="FFFFFF"/>
@@ -10944,11 +11101,12 @@
                   <a:srgbClr val="FFFFFF"/>
                 </a:solidFill>
               </a:rPr>
-              <a:t>    return sum(</a:t>
-            </a:r>
-          </a:p>
-          <a:p xmlns:a="http://schemas.openxmlformats.org/drawingml/2006/main">
-            <a:pPr algn="l">
+              <a:t>        f"{skill.name.replace('-', ' ')} {skill.description}"</a:t>
+            </a:r>
+          </a:p>
+          <a:p xmlns:a="http://schemas.openxmlformats.org/drawingml/2006/main">
+            <a:pPr algn="l">
+              <a:buNone/>
               <a:defRPr sz="1350" b="0">
                 <a:solidFill>
                   <a:srgbClr val="FFFFFF"/>
@@ -10961,11 +11119,12 @@
                   <a:srgbClr val="FFFFFF"/>
                 </a:solidFill>
               </a:rPr>
-              <a:t>        1 for word in task.lower().split()</a:t>
-            </a:r>
-          </a:p>
-          <a:p xmlns:a="http://schemas.openxmlformats.org/drawingml/2006/main">
-            <a:pPr algn="l">
+              <a:t>    )</a:t>
+            </a:r>
+          </a:p>
+          <a:p xmlns:a="http://schemas.openxmlformats.org/drawingml/2006/main">
+            <a:pPr algn="l">
+              <a:buNone/>
               <a:defRPr sz="1350" b="0">
                 <a:solidFill>
                   <a:srgbClr val="FFFFFF"/>
@@ -10978,24 +11137,7 @@
                   <a:srgbClr val="FFFFFF"/>
                 </a:solidFill>
               </a:rPr>
-              <a:t>        if word.strip(".,!?") in haystack</a:t>
-            </a:r>
-          </a:p>
-          <a:p xmlns:a="http://schemas.openxmlformats.org/drawingml/2006/main">
-            <a:pPr algn="l">
-              <a:defRPr sz="1350" b="0">
-                <a:solidFill>
-                  <a:srgbClr val="FFFFFF"/>
-                </a:solidFill>
-              </a:defRPr>
-            </a:pPr>
-            <a:r>
-              <a:rPr sz="1350" b="0">
-                <a:solidFill>
-                  <a:srgbClr val="FFFFFF"/>
-                </a:solidFill>
-              </a:rPr>
-              <a:t>    )</a:t>
+              <a:t>    return len(tokenize(task) &amp; haystack)</a:t>
             </a:r>
           </a:p>
         </p:txBody>
@@ -11066,6 +11208,7 @@
           <a:lstStyle xmlns:a="http://schemas.openxmlformats.org/drawingml/2006/main"/>
           <a:p xmlns:a="http://schemas.openxmlformats.org/drawingml/2006/main">
             <a:pPr algn="l">
+              <a:buNone/>
               <a:defRPr sz="1350" b="0">
                 <a:solidFill>
                   <a:srgbClr val="000000"/>
@@ -11147,6 +11290,7 @@
           <a:lstStyle xmlns:a="http://schemas.openxmlformats.org/drawingml/2006/main"/>
           <a:p xmlns:a="http://schemas.openxmlformats.org/drawingml/2006/main">
             <a:pPr algn="l">
+              <a:buNone/>
               <a:defRPr sz="2250" b="0">
                 <a:solidFill>
                   <a:srgbClr val="000000"/>
@@ -11197,6 +11341,7 @@
           <a:lstStyle xmlns:a="http://schemas.openxmlformats.org/drawingml/2006/main"/>
           <a:p xmlns:a="http://schemas.openxmlformats.org/drawingml/2006/main">
             <a:pPr algn="l">
+              <a:buNone/>
               <a:defRPr sz="1650" b="0">
                 <a:solidFill>
                   <a:srgbClr val="222222"/>
@@ -11247,6 +11392,7 @@
           <a:lstStyle xmlns:a="http://schemas.openxmlformats.org/drawingml/2006/main"/>
           <a:p xmlns:a="http://schemas.openxmlformats.org/drawingml/2006/main">
             <a:pPr algn="l">
+              <a:buNone/>
               <a:defRPr sz="1125" b="0">
                 <a:solidFill>
                   <a:srgbClr val="555555"/>
@@ -11297,6 +11443,7 @@
           <a:lstStyle xmlns:a="http://schemas.openxmlformats.org/drawingml/2006/main"/>
           <a:p xmlns:a="http://schemas.openxmlformats.org/drawingml/2006/main">
             <a:pPr algn="r">
+              <a:buNone/>
               <a:defRPr sz="1125" b="0">
                 <a:solidFill>
                   <a:srgbClr val="000000"/>
@@ -11376,6 +11523,7 @@
           <a:lstStyle xmlns:a="http://schemas.openxmlformats.org/drawingml/2006/main"/>
           <a:p xmlns:a="http://schemas.openxmlformats.org/drawingml/2006/main">
             <a:pPr algn="l">
+              <a:buNone/>
               <a:defRPr sz="2925" b="0">
                 <a:solidFill>
                   <a:srgbClr val="000000"/>
@@ -11426,6 +11574,7 @@
           <a:lstStyle xmlns:a="http://schemas.openxmlformats.org/drawingml/2006/main"/>
           <a:p xmlns:a="http://schemas.openxmlformats.org/drawingml/2006/main">
             <a:pPr algn="l">
+              <a:buNone/>
               <a:defRPr sz="1650" b="0">
                 <a:solidFill>
                   <a:srgbClr val="555555"/>
@@ -11476,6 +11625,7 @@
           <a:lstStyle xmlns:a="http://schemas.openxmlformats.org/drawingml/2006/main"/>
           <a:p xmlns:a="http://schemas.openxmlformats.org/drawingml/2006/main">
             <a:pPr algn="l">
+              <a:buNone/>
               <a:defRPr sz="1125" b="0">
                 <a:solidFill>
                   <a:srgbClr val="555555"/>
@@ -11526,6 +11676,7 @@
           <a:lstStyle xmlns:a="http://schemas.openxmlformats.org/drawingml/2006/main"/>
           <a:p xmlns:a="http://schemas.openxmlformats.org/drawingml/2006/main">
             <a:pPr algn="r">
+              <a:buNone/>
               <a:defRPr sz="1125" b="0">
                 <a:solidFill>
                   <a:srgbClr val="000000"/>
@@ -11576,6 +11727,7 @@
           <a:lstStyle xmlns:a="http://schemas.openxmlformats.org/drawingml/2006/main"/>
           <a:p xmlns:a="http://schemas.openxmlformats.org/drawingml/2006/main">
             <a:pPr algn="l">
+              <a:buNone/>
               <a:defRPr sz="4200" b="1">
                 <a:solidFill>
                   <a:srgbClr val="FF6B35"/>
@@ -11626,6 +11778,7 @@
           <a:lstStyle xmlns:a="http://schemas.openxmlformats.org/drawingml/2006/main"/>
           <a:p xmlns:a="http://schemas.openxmlformats.org/drawingml/2006/main">
             <a:pPr algn="l">
+              <a:buNone/>
               <a:defRPr sz="2550" b="0">
                 <a:solidFill>
                   <a:srgbClr val="000000"/>
@@ -11709,6 +11862,7 @@
           <a:lstStyle xmlns:a="http://schemas.openxmlformats.org/drawingml/2006/main"/>
           <a:p xmlns:a="http://schemas.openxmlformats.org/drawingml/2006/main">
             <a:pPr algn="l">
+              <a:buNone/>
               <a:defRPr sz="1200" b="1">
                 <a:solidFill>
                   <a:srgbClr val="555555"/>
@@ -11759,6 +11913,7 @@
           <a:lstStyle xmlns:a="http://schemas.openxmlformats.org/drawingml/2006/main"/>
           <a:p xmlns:a="http://schemas.openxmlformats.org/drawingml/2006/main">
             <a:pPr algn="l">
+              <a:buNone/>
               <a:defRPr sz="1950" b="0">
                 <a:solidFill>
                   <a:srgbClr val="000000"/>
@@ -11809,6 +11964,7 @@
           <a:lstStyle xmlns:a="http://schemas.openxmlformats.org/drawingml/2006/main"/>
           <a:p xmlns:a="http://schemas.openxmlformats.org/drawingml/2006/main">
             <a:pPr algn="l">
+              <a:buNone/>
               <a:defRPr sz="1350" b="0">
                 <a:solidFill>
                   <a:srgbClr val="222222"/>
@@ -11923,6 +12079,7 @@
           <a:lstStyle xmlns:a="http://schemas.openxmlformats.org/drawingml/2006/main"/>
           <a:p xmlns:a="http://schemas.openxmlformats.org/drawingml/2006/main">
             <a:pPr algn="l">
+              <a:buNone/>
               <a:defRPr sz="1200" b="1">
                 <a:solidFill>
                   <a:srgbClr val="555555"/>
@@ -11973,6 +12130,7 @@
           <a:lstStyle xmlns:a="http://schemas.openxmlformats.org/drawingml/2006/main"/>
           <a:p xmlns:a="http://schemas.openxmlformats.org/drawingml/2006/main">
             <a:pPr algn="l">
+              <a:buNone/>
               <a:defRPr sz="1950" b="0">
                 <a:solidFill>
                   <a:srgbClr val="000000"/>
@@ -12023,6 +12181,7 @@
           <a:lstStyle xmlns:a="http://schemas.openxmlformats.org/drawingml/2006/main"/>
           <a:p xmlns:a="http://schemas.openxmlformats.org/drawingml/2006/main">
             <a:pPr algn="l">
+              <a:buNone/>
               <a:defRPr sz="1350" b="0">
                 <a:solidFill>
                   <a:srgbClr val="222222"/>
@@ -12137,6 +12296,7 @@
           <a:lstStyle xmlns:a="http://schemas.openxmlformats.org/drawingml/2006/main"/>
           <a:p xmlns:a="http://schemas.openxmlformats.org/drawingml/2006/main">
             <a:pPr algn="l">
+              <a:buNone/>
               <a:defRPr sz="1200" b="1">
                 <a:solidFill>
                   <a:srgbClr val="555555"/>
@@ -12187,6 +12347,7 @@
           <a:lstStyle xmlns:a="http://schemas.openxmlformats.org/drawingml/2006/main"/>
           <a:p xmlns:a="http://schemas.openxmlformats.org/drawingml/2006/main">
             <a:pPr algn="l">
+              <a:buNone/>
               <a:defRPr sz="1950" b="0">
                 <a:solidFill>
                   <a:srgbClr val="000000"/>
@@ -12237,6 +12398,7 @@
           <a:lstStyle xmlns:a="http://schemas.openxmlformats.org/drawingml/2006/main"/>
           <a:p xmlns:a="http://schemas.openxmlformats.org/drawingml/2006/main">
             <a:pPr algn="l">
+              <a:buNone/>
               <a:defRPr sz="1350" b="0">
                 <a:solidFill>
                   <a:srgbClr val="222222"/>
@@ -12287,6 +12449,7 @@
           <a:lstStyle xmlns:a="http://schemas.openxmlformats.org/drawingml/2006/main"/>
           <a:p xmlns:a="http://schemas.openxmlformats.org/drawingml/2006/main">
             <a:pPr algn="l">
+              <a:buNone/>
               <a:defRPr sz="1125" b="0">
                 <a:solidFill>
                   <a:srgbClr val="555555"/>
@@ -12337,6 +12500,7 @@
           <a:lstStyle xmlns:a="http://schemas.openxmlformats.org/drawingml/2006/main"/>
           <a:p xmlns:a="http://schemas.openxmlformats.org/drawingml/2006/main">
             <a:pPr algn="r">
+              <a:buNone/>
               <a:defRPr sz="1125" b="0">
                 <a:solidFill>
                   <a:srgbClr val="000000"/>
@@ -12416,6 +12580,7 @@
           <a:lstStyle xmlns:a="http://schemas.openxmlformats.org/drawingml/2006/main"/>
           <a:p xmlns:a="http://schemas.openxmlformats.org/drawingml/2006/main">
             <a:pPr algn="l">
+              <a:buNone/>
               <a:defRPr sz="2925" b="0">
                 <a:solidFill>
                   <a:srgbClr val="000000"/>
@@ -12466,6 +12631,7 @@
           <a:lstStyle xmlns:a="http://schemas.openxmlformats.org/drawingml/2006/main"/>
           <a:p xmlns:a="http://schemas.openxmlformats.org/drawingml/2006/main">
             <a:pPr algn="l">
+              <a:buNone/>
               <a:defRPr sz="1650" b="0">
                 <a:solidFill>
                   <a:srgbClr val="555555"/>
@@ -12516,6 +12682,7 @@
           <a:lstStyle xmlns:a="http://schemas.openxmlformats.org/drawingml/2006/main"/>
           <a:p xmlns:a="http://schemas.openxmlformats.org/drawingml/2006/main">
             <a:pPr algn="l">
+              <a:buNone/>
               <a:defRPr sz="1125" b="0">
                 <a:solidFill>
                   <a:srgbClr val="555555"/>
@@ -12566,6 +12733,7 @@
           <a:lstStyle xmlns:a="http://schemas.openxmlformats.org/drawingml/2006/main"/>
           <a:p xmlns:a="http://schemas.openxmlformats.org/drawingml/2006/main">
             <a:pPr algn="r">
+              <a:buNone/>
               <a:defRPr sz="1125" b="0">
                 <a:solidFill>
                   <a:srgbClr val="000000"/>
@@ -12647,6 +12815,7 @@
           <a:lstStyle xmlns:a="http://schemas.openxmlformats.org/drawingml/2006/main"/>
           <a:p xmlns:a="http://schemas.openxmlformats.org/drawingml/2006/main">
             <a:pPr algn="l">
+              <a:buNone/>
               <a:defRPr sz="1200" b="1">
                 <a:solidFill>
                   <a:srgbClr val="FFFFFF"/>
@@ -12697,6 +12866,7 @@
           <a:lstStyle xmlns:a="http://schemas.openxmlformats.org/drawingml/2006/main"/>
           <a:p xmlns:a="http://schemas.openxmlformats.org/drawingml/2006/main">
             <a:pPr algn="l">
+              <a:buNone/>
               <a:defRPr sz="1350" b="0">
                 <a:solidFill>
                   <a:srgbClr val="FFFFFF"/>
@@ -12709,7 +12879,7 @@
                   <a:srgbClr val="FFFFFF"/>
                 </a:solidFill>
               </a:rPr>
-              <a:t>{"method": "tools/list"}</a:t>
+              <a:t>initialize → notifications/initialized</a:t>
             </a:r>
           </a:p>
           <a:p xmlns:a="http://schemas.openxmlformats.org/drawingml/2006/main">
@@ -12719,6 +12889,7 @@
           </a:p>
           <a:p xmlns:a="http://schemas.openxmlformats.org/drawingml/2006/main">
             <a:pPr algn="l">
+              <a:buNone/>
               <a:defRPr sz="1350" b="0">
                 <a:solidFill>
                   <a:srgbClr val="FFFFFF"/>
@@ -12731,11 +12902,12 @@
                   <a:srgbClr val="FFFFFF"/>
                 </a:solidFill>
               </a:rPr>
-              <a:t>{"method": "tools/call",</a:t>
-            </a:r>
-          </a:p>
-          <a:p xmlns:a="http://schemas.openxmlformats.org/drawingml/2006/main">
-            <a:pPr algn="l">
+              <a:t>{"jsonrpc":"2.0","id":2,"method":"tools/list"}</a:t>
+            </a:r>
+          </a:p>
+          <a:p xmlns:a="http://schemas.openxmlformats.org/drawingml/2006/main">
+            <a:pPr algn="l">
+              <a:buNone/>
               <a:defRPr sz="1350" b="0">
                 <a:solidFill>
                   <a:srgbClr val="FFFFFF"/>
@@ -12748,11 +12920,12 @@
                   <a:srgbClr val="FFFFFF"/>
                 </a:solidFill>
               </a:rPr>
-              <a:t> "params": {</a:t>
-            </a:r>
-          </a:p>
-          <a:p xmlns:a="http://schemas.openxmlformats.org/drawingml/2006/main">
-            <a:pPr algn="l">
+              <a:t/>
+            </a:r>
+          </a:p>
+          <a:p xmlns:a="http://schemas.openxmlformats.org/drawingml/2006/main">
+            <a:pPr algn="l">
+              <a:buNone/>
               <a:defRPr sz="1350" b="0">
                 <a:solidFill>
                   <a:srgbClr val="FFFFFF"/>
@@ -12765,11 +12938,12 @@
                   <a:srgbClr val="FFFFFF"/>
                 </a:solidFill>
               </a:rPr>
-              <a:t>   "name": "inventory.lookup",</a:t>
-            </a:r>
-          </a:p>
-          <a:p xmlns:a="http://schemas.openxmlformats.org/drawingml/2006/main">
-            <a:pPr algn="l">
+              <a:t>{"jsonrpc":"2.0","id":3,</a:t>
+            </a:r>
+          </a:p>
+          <a:p xmlns:a="http://schemas.openxmlformats.org/drawingml/2006/main">
+            <a:pPr algn="l">
+              <a:buNone/>
               <a:defRPr sz="1350" b="0">
                 <a:solidFill>
                   <a:srgbClr val="FFFFFF"/>
@@ -12782,11 +12956,12 @@
                   <a:srgbClr val="FFFFFF"/>
                 </a:solidFill>
               </a:rPr>
-              <a:t>   "arguments": {"sku": "sku-200"}</a:t>
-            </a:r>
-          </a:p>
-          <a:p xmlns:a="http://schemas.openxmlformats.org/drawingml/2006/main">
-            <a:pPr algn="l">
+              <a:t> "method":"tools/call",</a:t>
+            </a:r>
+          </a:p>
+          <a:p xmlns:a="http://schemas.openxmlformats.org/drawingml/2006/main">
+            <a:pPr algn="l">
+              <a:buNone/>
               <a:defRPr sz="1350" b="0">
                 <a:solidFill>
                   <a:srgbClr val="FFFFFF"/>
@@ -12799,7 +12974,25 @@
                   <a:srgbClr val="FFFFFF"/>
                 </a:solidFill>
               </a:rPr>
-              <a:t> }}</a:t>
+              <a:t> "params":{"name":"inventory.lookup",</a:t>
+            </a:r>
+          </a:p>
+          <a:p xmlns:a="http://schemas.openxmlformats.org/drawingml/2006/main">
+            <a:pPr algn="l">
+              <a:buNone/>
+              <a:defRPr sz="1350" b="0">
+                <a:solidFill>
+                  <a:srgbClr val="FFFFFF"/>
+                </a:solidFill>
+              </a:defRPr>
+            </a:pPr>
+            <a:r>
+              <a:rPr sz="1350" b="0">
+                <a:solidFill>
+                  <a:srgbClr val="FFFFFF"/>
+                </a:solidFill>
+              </a:rPr>
+              <a:t> "arguments":{"sku":"sku-200"}}}</a:t>
             </a:r>
           </a:p>
         </p:txBody>
@@ -12868,6 +13061,7 @@
           <a:lstStyle xmlns:a="http://schemas.openxmlformats.org/drawingml/2006/main"/>
           <a:p xmlns:a="http://schemas.openxmlformats.org/drawingml/2006/main">
             <a:pPr algn="l">
+              <a:buNone/>
               <a:defRPr sz="2100" b="0">
                 <a:solidFill>
                   <a:srgbClr val="000000"/>
@@ -12949,6 +13143,7 @@
           <a:lstStyle xmlns:a="http://schemas.openxmlformats.org/drawingml/2006/main"/>
           <a:p xmlns:a="http://schemas.openxmlformats.org/drawingml/2006/main">
             <a:pPr algn="l">
+              <a:buNone/>
               <a:defRPr sz="1650" b="0">
                 <a:solidFill>
                   <a:srgbClr val="222222"/>
@@ -13030,6 +13225,7 @@
           <a:lstStyle xmlns:a="http://schemas.openxmlformats.org/drawingml/2006/main"/>
           <a:p xmlns:a="http://schemas.openxmlformats.org/drawingml/2006/main">
             <a:pPr algn="l">
+              <a:buNone/>
               <a:defRPr sz="1650" b="0">
                 <a:solidFill>
                   <a:srgbClr val="222222"/>
@@ -13111,6 +13307,7 @@
           <a:lstStyle xmlns:a="http://schemas.openxmlformats.org/drawingml/2006/main"/>
           <a:p xmlns:a="http://schemas.openxmlformats.org/drawingml/2006/main">
             <a:pPr algn="l">
+              <a:buNone/>
               <a:defRPr sz="1650" b="0">
                 <a:solidFill>
                   <a:srgbClr val="222222"/>
@@ -13194,6 +13391,7 @@
           <a:lstStyle xmlns:a="http://schemas.openxmlformats.org/drawingml/2006/main"/>
           <a:p xmlns:a="http://schemas.openxmlformats.org/drawingml/2006/main">
             <a:pPr algn="l">
+              <a:buNone/>
               <a:defRPr sz="1350" b="0">
                 <a:solidFill>
                   <a:srgbClr val="000000"/>
@@ -13244,6 +13442,7 @@
           <a:lstStyle xmlns:a="http://schemas.openxmlformats.org/drawingml/2006/main"/>
           <a:p xmlns:a="http://schemas.openxmlformats.org/drawingml/2006/main">
             <a:pPr algn="l">
+              <a:buNone/>
               <a:defRPr sz="1125" b="0">
                 <a:solidFill>
                   <a:srgbClr val="555555"/>
@@ -13294,6 +13493,7 @@
           <a:lstStyle xmlns:a="http://schemas.openxmlformats.org/drawingml/2006/main"/>
           <a:p xmlns:a="http://schemas.openxmlformats.org/drawingml/2006/main">
             <a:pPr algn="r">
+              <a:buNone/>
               <a:defRPr sz="1125" b="0">
                 <a:solidFill>
                   <a:srgbClr val="000000"/>
@@ -13373,6 +13573,7 @@
           <a:lstStyle xmlns:a="http://schemas.openxmlformats.org/drawingml/2006/main"/>
           <a:p xmlns:a="http://schemas.openxmlformats.org/drawingml/2006/main">
             <a:pPr algn="l">
+              <a:buNone/>
               <a:defRPr sz="2925" b="0">
                 <a:solidFill>
                   <a:srgbClr val="000000"/>
@@ -13423,6 +13624,7 @@
           <a:lstStyle xmlns:a="http://schemas.openxmlformats.org/drawingml/2006/main"/>
           <a:p xmlns:a="http://schemas.openxmlformats.org/drawingml/2006/main">
             <a:pPr algn="l">
+              <a:buNone/>
               <a:defRPr sz="1650" b="0">
                 <a:solidFill>
                   <a:srgbClr val="555555"/>
@@ -13473,6 +13675,7 @@
           <a:lstStyle xmlns:a="http://schemas.openxmlformats.org/drawingml/2006/main"/>
           <a:p xmlns:a="http://schemas.openxmlformats.org/drawingml/2006/main">
             <a:pPr algn="l">
+              <a:buNone/>
               <a:defRPr sz="1125" b="0">
                 <a:solidFill>
                   <a:srgbClr val="555555"/>
@@ -13523,6 +13726,7 @@
           <a:lstStyle xmlns:a="http://schemas.openxmlformats.org/drawingml/2006/main"/>
           <a:p xmlns:a="http://schemas.openxmlformats.org/drawingml/2006/main">
             <a:pPr algn="r">
+              <a:buNone/>
               <a:defRPr sz="1125" b="0">
                 <a:solidFill>
                   <a:srgbClr val="000000"/>
@@ -13573,6 +13777,7 @@
           <a:lstStyle xmlns:a="http://schemas.openxmlformats.org/drawingml/2006/main"/>
           <a:p xmlns:a="http://schemas.openxmlformats.org/drawingml/2006/main">
             <a:pPr algn="l">
+              <a:buNone/>
               <a:defRPr sz="4200" b="1">
                 <a:solidFill>
                   <a:srgbClr val="FF6B35"/>
@@ -13623,6 +13828,7 @@
           <a:lstStyle xmlns:a="http://schemas.openxmlformats.org/drawingml/2006/main"/>
           <a:p xmlns:a="http://schemas.openxmlformats.org/drawingml/2006/main">
             <a:pPr algn="l">
+              <a:buNone/>
               <a:defRPr sz="2550" b="0">
                 <a:solidFill>
                   <a:srgbClr val="000000"/>
@@ -13704,6 +13910,7 @@
           <a:lstStyle xmlns:a="http://schemas.openxmlformats.org/drawingml/2006/main"/>
           <a:p xmlns:a="http://schemas.openxmlformats.org/drawingml/2006/main">
             <a:pPr algn="l">
+              <a:buNone/>
               <a:defRPr sz="2025" b="0">
                 <a:solidFill>
                   <a:srgbClr val="000000"/>
@@ -13754,6 +13961,7 @@
           <a:lstStyle xmlns:a="http://schemas.openxmlformats.org/drawingml/2006/main"/>
           <a:p xmlns:a="http://schemas.openxmlformats.org/drawingml/2006/main">
             <a:pPr algn="l">
+              <a:buNone/>
               <a:defRPr sz="1500" b="0">
                 <a:solidFill>
                   <a:srgbClr val="222222"/>
@@ -13837,6 +14045,7 @@
           <a:lstStyle xmlns:a="http://schemas.openxmlformats.org/drawingml/2006/main"/>
           <a:p xmlns:a="http://schemas.openxmlformats.org/drawingml/2006/main">
             <a:pPr algn="l">
+              <a:buNone/>
               <a:defRPr sz="2025" b="0">
                 <a:solidFill>
                   <a:srgbClr val="000000"/>
@@ -13887,6 +14096,7 @@
           <a:lstStyle xmlns:a="http://schemas.openxmlformats.org/drawingml/2006/main"/>
           <a:p xmlns:a="http://schemas.openxmlformats.org/drawingml/2006/main">
             <a:pPr algn="l">
+              <a:buNone/>
               <a:defRPr sz="1500" b="0">
                 <a:solidFill>
                   <a:srgbClr val="222222"/>
@@ -13968,6 +14178,7 @@
           <a:lstStyle xmlns:a="http://schemas.openxmlformats.org/drawingml/2006/main"/>
           <a:p xmlns:a="http://schemas.openxmlformats.org/drawingml/2006/main">
             <a:pPr algn="ctr">
+              <a:buNone/>
               <a:defRPr sz="1200" b="0">
                 <a:solidFill>
                   <a:srgbClr val="555555"/>
@@ -14018,6 +14229,7 @@
           <a:lstStyle xmlns:a="http://schemas.openxmlformats.org/drawingml/2006/main"/>
           <a:p xmlns:a="http://schemas.openxmlformats.org/drawingml/2006/main">
             <a:pPr algn="l">
+              <a:buNone/>
               <a:defRPr sz="1875" b="0">
                 <a:solidFill>
                   <a:srgbClr val="000000"/>
@@ -14068,6 +14280,7 @@
           <a:lstStyle xmlns:a="http://schemas.openxmlformats.org/drawingml/2006/main"/>
           <a:p xmlns:a="http://schemas.openxmlformats.org/drawingml/2006/main">
             <a:pPr algn="l">
+              <a:buNone/>
               <a:defRPr sz="1125" b="0">
                 <a:solidFill>
                   <a:srgbClr val="555555"/>
@@ -14118,6 +14331,7 @@
           <a:lstStyle xmlns:a="http://schemas.openxmlformats.org/drawingml/2006/main"/>
           <a:p xmlns:a="http://schemas.openxmlformats.org/drawingml/2006/main">
             <a:pPr algn="r">
+              <a:buNone/>
               <a:defRPr sz="1125" b="0">
                 <a:solidFill>
                   <a:srgbClr val="000000"/>

</xml_diff>